<commit_message>
mise a jour du repo
</commit_message>
<xml_diff>
--- a/docs/TOTP.pptx
+++ b/docs/TOTP.pptx
@@ -216,7 +216,7 @@
           <a:p>
             <a:fld id="{66076575-1B33-4328-A7DF-AD20E8AA1386}" type="datetimeFigureOut">
               <a:rPr lang="fr-FR" smtClean="0"/>
-              <a:t>19/12/2025</a:t>
+              <a:t>06/01/2026</a:t>
             </a:fld>
             <a:endParaRPr lang="fr-FR"/>
           </a:p>
@@ -3554,7 +3554,7 @@
                   <a:srgbClr val="94A3B8"/>
                 </a:solidFill>
               </a:rPr>
-              <a:t>19/12/2025</a:t>
+              <a:t>06/01/2026</a:t>
             </a:fld>
             <a:endParaRPr lang="fr-FR" dirty="0">
               <a:solidFill>
@@ -3833,7 +3833,7 @@
                   <a:srgbClr val="94A3B8"/>
                 </a:solidFill>
               </a:rPr>
-              <a:t>19/12/2025</a:t>
+              <a:t>06/01/2026</a:t>
             </a:fld>
             <a:endParaRPr lang="fr-FR" dirty="0">
               <a:solidFill>
@@ -4102,7 +4102,7 @@
                   <a:srgbClr val="94A3B8"/>
                 </a:solidFill>
               </a:rPr>
-              <a:t>19/12/2025</a:t>
+              <a:t>06/01/2026</a:t>
             </a:fld>
             <a:endParaRPr lang="fr-FR" dirty="0">
               <a:solidFill>
@@ -4476,7 +4476,7 @@
                   <a:srgbClr val="94A3B8"/>
                 </a:solidFill>
               </a:rPr>
-              <a:t>19/12/2025</a:t>
+              <a:t>06/01/2026</a:t>
             </a:fld>
             <a:endParaRPr lang="fr-FR" dirty="0">
               <a:solidFill>
@@ -4651,7 +4651,7 @@
             </a:pPr>
             <a:r>
               <a:rPr lang="fr-FR" sz="2200" dirty="0"/>
-              <a:t>L'utilisateur se connecte avec son login / mot de passe et n'a pas encore de TOTP activé sur son compte.</a:t>
+              <a:t>L'utilisateur se connecte avec son login / mot de passe et n'a pas encore enregistré de token TOTP sur son compte.</a:t>
             </a:r>
           </a:p>
           <a:p>
@@ -4661,7 +4661,7 @@
             </a:pPr>
             <a:r>
               <a:rPr lang="fr-FR" sz="2200" dirty="0"/>
-              <a:t>Kelio propose d'activer le MFA TOTP et déclenche la génération d'un secret partagé.</a:t>
+              <a:t>MFA TOTP activé, Kelio déclenche la génération d'un secret partagé.</a:t>
             </a:r>
           </a:p>
           <a:p>
@@ -4681,7 +4681,7 @@
             </a:pPr>
             <a:r>
               <a:rPr lang="fr-FR" sz="2200" dirty="0"/>
-              <a:t>L'utilisateur est invité à scanner un QR code avec son application d'authentification.</a:t>
+              <a:t>L'utilisateur est invité à scanner un QR code ou saisir le secret selon  son application d'authentification.</a:t>
             </a:r>
           </a:p>
         </p:txBody>
@@ -4760,7 +4760,7 @@
                   <a:srgbClr val="94A3B8"/>
                 </a:solidFill>
               </a:rPr>
-              <a:t>19/12/2025</a:t>
+              <a:t>06/01/2026</a:t>
             </a:fld>
             <a:endParaRPr lang="fr-FR" dirty="0">
               <a:solidFill>
@@ -5071,7 +5071,7 @@
                   <a:srgbClr val="94A3B8"/>
                 </a:solidFill>
               </a:rPr>
-              <a:t>19/12/2025</a:t>
+              <a:t>06/01/2026</a:t>
             </a:fld>
             <a:endParaRPr lang="fr-FR" dirty="0">
               <a:solidFill>
@@ -5354,7 +5354,7 @@
                   <a:srgbClr val="94A3B8"/>
                 </a:solidFill>
               </a:rPr>
-              <a:t>19/12/2025</a:t>
+              <a:t>06/01/2026</a:t>
             </a:fld>
             <a:endParaRPr lang="fr-FR" dirty="0">
               <a:solidFill>
@@ -5652,7 +5652,7 @@
                   <a:srgbClr val="94A3B8"/>
                 </a:solidFill>
               </a:rPr>
-              <a:t>19/12/2025</a:t>
+              <a:t>06/01/2026</a:t>
             </a:fld>
             <a:endParaRPr lang="fr-FR" dirty="0">
               <a:solidFill>
@@ -5954,7 +5954,7 @@
                   <a:srgbClr val="94A3B8"/>
                 </a:solidFill>
               </a:rPr>
-              <a:t>19/12/2025</a:t>
+              <a:t>06/01/2026</a:t>
             </a:fld>
             <a:endParaRPr lang="fr-FR" dirty="0">
               <a:solidFill>
@@ -6256,7 +6256,7 @@
                   <a:srgbClr val="94A3B8"/>
                 </a:solidFill>
               </a:rPr>
-              <a:t>19/12/2025</a:t>
+              <a:t>06/01/2026</a:t>
             </a:fld>
             <a:endParaRPr lang="fr-FR" dirty="0">
               <a:solidFill>
@@ -6659,7 +6659,7 @@
                   <a:srgbClr val="94A3B8"/>
                 </a:solidFill>
               </a:rPr>
-              <a:t>19/12/2025</a:t>
+              <a:t>06/01/2026</a:t>
             </a:fld>
             <a:endParaRPr lang="fr-FR" dirty="0">
               <a:solidFill>
@@ -6847,12 +6847,8 @@
               <a:t>Expliquer comment la librairie </a:t>
             </a:r>
             <a:r>
-              <a:rPr lang="fr-FR" b="1" dirty="0" err="1"/>
-              <a:t>otp</a:t>
-            </a:r>
-            <a:r>
               <a:rPr lang="fr-FR" b="1" dirty="0"/>
-              <a:t>-java</a:t>
+              <a:t>otp-java</a:t>
             </a:r>
             <a:r>
               <a:rPr lang="fr-FR" dirty="0"/>
@@ -6970,7 +6966,7 @@
                   <a:srgbClr val="94A3B8"/>
                 </a:solidFill>
               </a:rPr>
-              <a:t>19/12/2025</a:t>
+              <a:t>06/01/2026</a:t>
             </a:fld>
             <a:endParaRPr lang="fr-FR" dirty="0">
               <a:solidFill>
@@ -7581,7 +7577,7 @@
                   <a:srgbClr val="94A3B8"/>
                 </a:solidFill>
               </a:rPr>
-              <a:t>19/12/2025</a:t>
+              <a:t>06/01/2026</a:t>
             </a:fld>
             <a:endParaRPr lang="fr-FR" dirty="0">
               <a:solidFill>
@@ -7780,7 +7776,7 @@
             </a:pPr>
             <a:r>
               <a:rPr lang="fr-FR" sz="2200" dirty="0"/>
-              <a:t>Calcul du HMAC (SHA‑1 par défaut), puis dynamic truncation et réduction modulo 10^digits.</a:t>
+              <a:t>Calcul du HMAC (SHA‑1 par défaut), puis dynamic truncation et réduction modulo 10^d.</a:t>
             </a:r>
           </a:p>
           <a:p>
@@ -7884,7 +7880,7 @@
                   <a:srgbClr val="94A3B8"/>
                 </a:solidFill>
               </a:rPr>
-              <a:t>19/12/2025</a:t>
+              <a:t>06/01/2026</a:t>
             </a:fld>
             <a:endParaRPr lang="fr-FR" dirty="0">
               <a:solidFill>
@@ -8097,7 +8093,7 @@
             </a:pPr>
             <a:r>
               <a:rPr lang="fr-FR" dirty="0"/>
-              <a:t>L'utilisateur recopie le code reçu dans l'écran de vérification Kelio pour finaliser l'authentification.</a:t>
+              <a:t>L'utilisateur recopie le code reçu dans l'écran de vérification Kelio pour finaliser l'authentification dans un délai défini en ?dur? de 5 minutes.</a:t>
             </a:r>
             <a:endParaRPr lang="fr-FR" dirty="0">
               <a:solidFill>
@@ -8181,7 +8177,7 @@
                   <a:srgbClr val="94A3B8"/>
                 </a:solidFill>
               </a:rPr>
-              <a:t>19/12/2025</a:t>
+              <a:t>06/01/2026</a:t>
             </a:fld>
             <a:endParaRPr lang="fr-FR" dirty="0">
               <a:solidFill>
@@ -8356,15 +8352,7 @@
             </a:pPr>
             <a:r>
               <a:rPr lang="fr-FR" sz="2200" dirty="0"/>
-              <a:t>Utilisation de la librairie Java </a:t>
-            </a:r>
-            <a:r>
-              <a:rPr lang="fr-FR" sz="2200" dirty="0" err="1"/>
-              <a:t>otp</a:t>
-            </a:r>
-            <a:r>
-              <a:rPr lang="fr-FR" sz="2200" dirty="0"/>
-              <a:t>-java de Bastiaan Jansen (HOTP &amp; TOTP conformes RFC 4226 / 6238).</a:t>
+              <a:t>Utilisation de la librairie Java otp-java de Bastiaan Jansen (HOTP &amp; TOTP conformes RFC 4226 / 6238).</a:t>
             </a:r>
           </a:p>
           <a:p>
@@ -8478,7 +8466,7 @@
                   <a:srgbClr val="94A3B8"/>
                 </a:solidFill>
               </a:rPr>
-              <a:t>19/12/2025</a:t>
+              <a:t>06/01/2026</a:t>
             </a:fld>
             <a:endParaRPr lang="fr-FR" dirty="0">
               <a:solidFill>
@@ -8775,7 +8763,7 @@
                   <a:srgbClr val="94A3B8"/>
                 </a:solidFill>
               </a:rPr>
-              <a:t>19/12/2025</a:t>
+              <a:t>06/01/2026</a:t>
             </a:fld>
             <a:endParaRPr lang="fr-FR" dirty="0">
               <a:solidFill>
@@ -9064,7 +9052,7 @@
                   <a:srgbClr val="94A3B8"/>
                 </a:solidFill>
               </a:rPr>
-              <a:t>19/12/2025</a:t>
+              <a:t>06/01/2026</a:t>
             </a:fld>
             <a:endParaRPr lang="fr-FR" dirty="0">
               <a:solidFill>
@@ -9239,15 +9227,7 @@
             </a:pPr>
             <a:r>
               <a:rPr lang="fr-FR" sz="2200" dirty="0"/>
-              <a:t>Standard de fait du marché (Google Authenticator, Microsoft Authenticator, </a:t>
-            </a:r>
-            <a:r>
-              <a:rPr lang="fr-FR" sz="2200" dirty="0" err="1"/>
-              <a:t>FreeOTP</a:t>
-            </a:r>
-            <a:r>
-              <a:rPr lang="fr-FR" sz="2200" dirty="0"/>
-              <a:t>, etc.).</a:t>
+              <a:t>Standard de fait du marché (Google Authenticator, Microsoft Authenticator, FreeOTP, etc.).</a:t>
             </a:r>
           </a:p>
           <a:p>
@@ -9360,7 +9340,7 @@
                   <a:srgbClr val="94A3B8"/>
                 </a:solidFill>
               </a:rPr>
-              <a:t>19/12/2025</a:t>
+              <a:t>06/01/2026</a:t>
             </a:fld>
             <a:endParaRPr lang="fr-FR" dirty="0">
               <a:solidFill>

</xml_diff>